<commit_message>
Add Merchant Services slide for sellers with iPhone Air
Introduce slide 8 covering Tap to Pay on iPhone, Apple Pay for Business,
and seller upgrade path via iPhone Air (99). Links to apple.com/shop/buy-
iphone/iphone-air. Extend action plan to 4 steps with Merchant Services.

Co-authored-by: Mohamed  <garlobrian52@users.noreply.github.com>
</commit_message>
<xml_diff>
--- a/presentations/apple-fy2025-environmental/Apple_FY2025_Environmental_Progress.pptx
+++ b/presentations/apple-fy2025-environmental/Apple_FY2025_Environmental_Progress.pptx
@@ -13,6 +13,7 @@
     <p:sldId id="261" r:id="rId13"/>
     <p:sldId id="262" r:id="rId14"/>
     <p:sldId id="263" r:id="rId15"/>
+    <p:sldId id="264" r:id="rId16"/>
   </p:sldIdLst>
   <p:sldSz cx="12191695" cy="6858000" type="screen4x3"/>
   <p:notesSz cx="6858000" cy="9144000"/>
@@ -955,6 +956,76 @@
 </file>
 
 <file path=ppt/notesSlides/notesSlide8.xml><?xml version="1.0" encoding="utf-8"?>
+<p:notes xmlns:a="http://schemas.openxmlformats.org/drawingml/2006/main" xmlns:p="http://schemas.openxmlformats.org/presentationml/2006/main" xmlns:r="http://schemas.openxmlformats.org/officeDocument/2006/relationships">
+  <p:cSld>
+    <p:spTree>
+      <p:nvGrpSpPr>
+        <p:cNvPr id="1" name=""/>
+        <p:cNvGrpSpPr/>
+        <p:nvPr/>
+      </p:nvGrpSpPr>
+      <p:grpSpPr>
+        <a:xfrm>
+          <a:off x="0" y="0"/>
+          <a:ext cx="0" cy="0"/>
+          <a:chOff x="0" y="0"/>
+          <a:chExt cx="0" cy="0"/>
+        </a:xfrm>
+      </p:grpSpPr>
+      <p:sp>
+        <p:nvSpPr>
+          <p:cNvPr id="2" name="Slide Image Placeholder 1"/>
+          <p:cNvSpPr>
+            <a:spLocks noGrp="1"/>
+          </p:cNvSpPr>
+          <p:nvPr>
+            <p:ph type="sldImg" idx="2"/>
+          </p:nvPr>
+        </p:nvSpPr>
+        <p:spPr/>
+      </p:sp>
+      <p:sp>
+        <p:nvSpPr>
+          <p:cNvPr id="3" name="Notes Placeholder 2"/>
+          <p:cNvSpPr>
+            <a:spLocks noGrp="1"/>
+          </p:cNvSpPr>
+          <p:nvPr>
+            <p:ph type="body" idx="3" sz="quarter"/>
+          </p:nvPr>
+        </p:nvSpPr>
+        <p:spPr/>
+        <p:txBody>
+          <a:bodyPr/>
+          <a:lstStyle/>
+          <a:p>
+            <a:r>
+              <a:t>Merchant Services extends our environmental and premium-brand story into the seller ecosystem. iPhone Air enables Tap to Pay on iPhone — sellers accept Apple Pay and contactless cards with no additional hardware. Direct sellers to apple.com/shop/buy-iphone/iphone-air for fleet upgrades.</a:t>
+            </a:r>
+          </a:p>
+        </p:txBody>
+      </p:sp>
+      <p:sp>
+        <p:nvSpPr>
+          <p:cNvPr id="4" name="Slide Number Placeholder 3"/>
+          <p:cNvSpPr>
+            <a:spLocks noGrp="1"/>
+          </p:cNvSpPr>
+          <p:nvPr>
+            <p:ph type="sldNum" idx="5" sz="quarter"/>
+          </p:nvPr>
+        </p:nvSpPr>
+        <p:spPr/>
+      </p:sp>
+    </p:spTree>
+  </p:cSld>
+  <p:clrMapOvr>
+    <a:masterClrMapping/>
+  </p:clrMapOvr>
+</p:notes>
+</file>
+
+<file path=ppt/notesSlides/notesSlide9.xml><?xml version="1.0" encoding="utf-8"?>
 <p:notes xmlns:a="http://schemas.openxmlformats.org/drawingml/2006/main" xmlns:p="http://schemas.openxmlformats.org/presentationml/2006/main" xmlns:r="http://schemas.openxmlformats.org/officeDocument/2006/relationships">
   <p:cSld>
     <p:spTree>
@@ -6395,7 +6466,7 @@
         <p:spPr>
           <a:xfrm>
             <a:off x="640080" y="457200"/>
-            <a:ext cx="10972800" cy="731520"/>
+            <a:ext cx="5486400" cy="914400"/>
           </a:xfrm>
           <a:prstGeom prst="rect">
             <a:avLst/>
@@ -6409,34 +6480,174 @@
           <a:lstStyle/>
           <a:p>
             <a:pPr algn="l">
-              <a:defRPr sz="2600" b="1">
+              <a:defRPr sz="2400" b="1">
                 <a:solidFill>
                   <a:srgbClr val="1D1D1F"/>
                 </a:solidFill>
               </a:defRPr>
             </a:pPr>
             <a:r>
-              <a:t>Leveraging FY25 Wins in the Market (Action Plan)</a:t>
-            </a:r>
-          </a:p>
-        </p:txBody>
-      </p:sp>
-      <p:sp>
-        <p:nvSpPr>
-          <p:cNvPr id="3" name="Rounded Rectangle 2"/>
+              <a:t>Merchant Services: Empowering Sellers with iPhone Air</a:t>
+            </a:r>
+          </a:p>
+        </p:txBody>
+      </p:sp>
+      <p:sp>
+        <p:nvSpPr>
+          <p:cNvPr id="3" name="TextBox 2"/>
+          <p:cNvSpPr txBox="1"/>
+          <p:nvPr/>
+        </p:nvSpPr>
+        <p:spPr>
+          <a:xfrm>
+            <a:off x="822960" y="1645920"/>
+            <a:ext cx="5303520" cy="640080"/>
+          </a:xfrm>
+          <a:prstGeom prst="rect">
+            <a:avLst/>
+          </a:prstGeom>
+          <a:noFill/>
+        </p:spPr>
+        <p:txBody>
+          <a:bodyPr wrap="square">
+            <a:spAutoFit/>
+          </a:bodyPr>
+          <a:lstStyle/>
+          <a:p>
+            <a:pPr algn="l">
+              <a:defRPr sz="1400" b="0">
+                <a:solidFill>
+                  <a:srgbClr val="1D1D1F"/>
+                </a:solidFill>
+              </a:defRPr>
+            </a:pPr>
+            <a:r>
+              <a:t>•  Tap to Pay on iPhone: Accept contactless payments with no extra hardware.</a:t>
+            </a:r>
+          </a:p>
+        </p:txBody>
+      </p:sp>
+      <p:sp>
+        <p:nvSpPr>
+          <p:cNvPr id="4" name="TextBox 3"/>
+          <p:cNvSpPr txBox="1"/>
+          <p:nvPr/>
+        </p:nvSpPr>
+        <p:spPr>
+          <a:xfrm>
+            <a:off x="822960" y="2331720"/>
+            <a:ext cx="5303520" cy="640080"/>
+          </a:xfrm>
+          <a:prstGeom prst="rect">
+            <a:avLst/>
+          </a:prstGeom>
+          <a:noFill/>
+        </p:spPr>
+        <p:txBody>
+          <a:bodyPr wrap="square">
+            <a:spAutoFit/>
+          </a:bodyPr>
+          <a:lstStyle/>
+          <a:p>
+            <a:pPr algn="l">
+              <a:defRPr sz="1400" b="0">
+                <a:solidFill>
+                  <a:srgbClr val="1D1D1F"/>
+                </a:solidFill>
+              </a:defRPr>
+            </a:pPr>
+            <a:r>
+              <a:t>•  Apple Pay for Business: Faster checkout and higher conversion.</a:t>
+            </a:r>
+          </a:p>
+        </p:txBody>
+      </p:sp>
+      <p:sp>
+        <p:nvSpPr>
+          <p:cNvPr id="5" name="TextBox 4"/>
+          <p:cNvSpPr txBox="1"/>
+          <p:nvPr/>
+        </p:nvSpPr>
+        <p:spPr>
+          <a:xfrm>
+            <a:off x="822960" y="3017520"/>
+            <a:ext cx="5303520" cy="640080"/>
+          </a:xfrm>
+          <a:prstGeom prst="rect">
+            <a:avLst/>
+          </a:prstGeom>
+          <a:noFill/>
+        </p:spPr>
+        <p:txBody>
+          <a:bodyPr wrap="square">
+            <a:spAutoFit/>
+          </a:bodyPr>
+          <a:lstStyle/>
+          <a:p>
+            <a:pPr algn="l">
+              <a:defRPr sz="1400" b="0">
+                <a:solidFill>
+                  <a:srgbClr val="1D1D1F"/>
+                </a:solidFill>
+              </a:defRPr>
+            </a:pPr>
+            <a:r>
+              <a:t>•  Seller Upgrade Path: Equip partners with iPhone Air from $999.</a:t>
+            </a:r>
+          </a:p>
+        </p:txBody>
+      </p:sp>
+      <p:sp>
+        <p:nvSpPr>
+          <p:cNvPr id="6" name="TextBox 5"/>
+          <p:cNvSpPr txBox="1"/>
+          <p:nvPr/>
+        </p:nvSpPr>
+        <p:spPr>
+          <a:xfrm>
+            <a:off x="822960" y="3840480"/>
+            <a:ext cx="5029200" cy="365760"/>
+          </a:xfrm>
+          <a:prstGeom prst="rect">
+            <a:avLst/>
+          </a:prstGeom>
+          <a:noFill/>
+        </p:spPr>
+        <p:txBody>
+          <a:bodyPr wrap="square">
+            <a:spAutoFit/>
+          </a:bodyPr>
+          <a:lstStyle/>
+          <a:p>
+            <a:pPr algn="l">
+              <a:defRPr sz="1200" b="1">
+                <a:solidFill>
+                  <a:srgbClr val="1A7F37"/>
+                </a:solidFill>
+              </a:defRPr>
+            </a:pPr>
+            <a:r>
+              <a:t>apple.com/shop/buy-iphone/iphone-air</a:t>
+            </a:r>
+          </a:p>
+        </p:txBody>
+      </p:sp>
+      <p:sp>
+        <p:nvSpPr>
+          <p:cNvPr id="7" name="Rounded Rectangle 6"/>
           <p:cNvSpPr/>
           <p:nvPr/>
         </p:nvSpPr>
         <p:spPr>
           <a:xfrm>
-            <a:off x="640080" y="1828800"/>
-            <a:ext cx="3474720" cy="3474720"/>
+            <a:off x="7772400" y="1371600"/>
+            <a:ext cx="2011680" cy="3840480"/>
           </a:xfrm>
           <a:prstGeom prst="roundRect">
             <a:avLst/>
           </a:prstGeom>
           <a:solidFill>
-            <a:srgbClr val="F5F5F7"/>
+            <a:srgbClr val="1D1D1F"/>
           </a:solidFill>
           <a:ln>
             <a:noFill/>
@@ -6466,20 +6677,20 @@
       </p:sp>
       <p:sp>
         <p:nvSpPr>
-          <p:cNvPr id="4" name="Oval 3"/>
+          <p:cNvPr id="8" name="Rounded Rectangle 7"/>
           <p:cNvSpPr/>
           <p:nvPr/>
         </p:nvSpPr>
         <p:spPr>
           <a:xfrm>
-            <a:off x="914400" y="2103120"/>
-            <a:ext cx="457200" cy="457200"/>
-          </a:xfrm>
-          <a:prstGeom prst="ellipse">
+            <a:off x="7955279" y="1645920"/>
+            <a:ext cx="1645920" cy="3108960"/>
+          </a:xfrm>
+          <a:prstGeom prst="roundRect">
             <a:avLst/>
           </a:prstGeom>
           <a:solidFill>
-            <a:srgbClr val="1A7F37"/>
+            <a:srgbClr val="F5F5F7"/>
           </a:solidFill>
           <a:ln>
             <a:noFill/>
@@ -6509,14 +6720,14 @@
       </p:sp>
       <p:sp>
         <p:nvSpPr>
-          <p:cNvPr id="5" name="TextBox 4"/>
+          <p:cNvPr id="9" name="TextBox 8"/>
           <p:cNvSpPr txBox="1"/>
           <p:nvPr/>
         </p:nvSpPr>
         <p:spPr>
           <a:xfrm>
-            <a:off x="914400" y="2148840"/>
-            <a:ext cx="457200" cy="365760"/>
+            <a:off x="7955279" y="2560320"/>
+            <a:ext cx="1645920" cy="365760"/>
           </a:xfrm>
           <a:prstGeom prst="rect">
             <a:avLst/>
@@ -6530,28 +6741,28 @@
           <a:lstStyle/>
           <a:p>
             <a:pPr algn="ctr">
-              <a:defRPr sz="1400" b="1">
-                <a:solidFill>
-                  <a:srgbClr val="FFFFFF"/>
+              <a:defRPr sz="1100" b="1">
+                <a:solidFill>
+                  <a:srgbClr val="1D1D1F"/>
                 </a:solidFill>
               </a:defRPr>
             </a:pPr>
             <a:r>
-              <a:t>1</a:t>
-            </a:r>
-          </a:p>
-        </p:txBody>
-      </p:sp>
-      <p:sp>
-        <p:nvSpPr>
-          <p:cNvPr id="6" name="TextBox 5"/>
+              <a:t>Tap to Pay</a:t>
+            </a:r>
+          </a:p>
+        </p:txBody>
+      </p:sp>
+      <p:sp>
+        <p:nvSpPr>
+          <p:cNvPr id="10" name="TextBox 9"/>
           <p:cNvSpPr txBox="1"/>
           <p:nvPr/>
         </p:nvSpPr>
         <p:spPr>
           <a:xfrm>
-            <a:off x="914400" y="2743200"/>
-            <a:ext cx="2926080" cy="457200"/>
+            <a:off x="7955279" y="2926080"/>
+            <a:ext cx="1645920" cy="457200"/>
           </a:xfrm>
           <a:prstGeom prst="rect">
             <a:avLst/>
@@ -6564,29 +6775,29 @@
           </a:bodyPr>
           <a:lstStyle/>
           <a:p>
-            <a:pPr algn="l">
+            <a:pPr algn="ctr">
               <a:defRPr sz="1600" b="1">
                 <a:solidFill>
-                  <a:srgbClr val="1D1D1F"/>
+                  <a:srgbClr val="1A7F37"/>
                 </a:solidFill>
               </a:defRPr>
             </a:pPr>
             <a:r>
-              <a:t>Enterprise Pitch Decks</a:t>
-            </a:r>
-          </a:p>
-        </p:txBody>
-      </p:sp>
-      <p:sp>
-        <p:nvSpPr>
-          <p:cNvPr id="7" name="TextBox 6"/>
+              <a:t>$999.00</a:t>
+            </a:r>
+          </a:p>
+        </p:txBody>
+      </p:sp>
+      <p:sp>
+        <p:nvSpPr>
+          <p:cNvPr id="11" name="TextBox 10"/>
           <p:cNvSpPr txBox="1"/>
           <p:nvPr/>
         </p:nvSpPr>
         <p:spPr>
           <a:xfrm>
-            <a:off x="914400" y="3291840"/>
-            <a:ext cx="2926080" cy="1371600"/>
+            <a:off x="7132320" y="5486400"/>
+            <a:ext cx="3474720" cy="457200"/>
           </a:xfrm>
           <a:prstGeom prst="rect">
             <a:avLst/>
@@ -6599,29 +6810,90 @@
           </a:bodyPr>
           <a:lstStyle/>
           <a:p>
+            <a:pPr algn="ctr">
+              <a:defRPr sz="1000" b="0">
+                <a:solidFill>
+                  <a:srgbClr val="6E6E73"/>
+                </a:solidFill>
+              </a:defRPr>
+            </a:pPr>
+            <a:r>
+              <a:t>The thinnest iPhone ever — now your sellers' point of sale.</a:t>
+            </a:r>
+          </a:p>
+        </p:txBody>
+      </p:sp>
+    </p:spTree>
+  </p:cSld>
+  <p:clrMapOvr>
+    <a:masterClrMapping/>
+  </p:clrMapOvr>
+</p:sld>
+</file>
+
+<file path=ppt/slides/slide9.xml><?xml version="1.0" encoding="utf-8"?>
+<p:sld xmlns:a="http://schemas.openxmlformats.org/drawingml/2006/main" xmlns:p="http://schemas.openxmlformats.org/presentationml/2006/main" xmlns:r="http://schemas.openxmlformats.org/officeDocument/2006/relationships">
+  <p:cSld>
+    <p:bg>
+      <p:bgPr>
+        <a:solidFill>
+          <a:srgbClr val="FFFFFF"/>
+        </a:solidFill>
+        <a:effectLst/>
+      </p:bgPr>
+    </p:bg>
+    <p:spTree>
+      <p:nvGrpSpPr>
+        <p:cNvPr id="1" name=""/>
+        <p:cNvGrpSpPr/>
+        <p:nvPr/>
+      </p:nvGrpSpPr>
+      <p:grpSpPr/>
+      <p:sp>
+        <p:nvSpPr>
+          <p:cNvPr id="2" name="TextBox 1"/>
+          <p:cNvSpPr txBox="1"/>
+          <p:nvPr/>
+        </p:nvSpPr>
+        <p:spPr>
+          <a:xfrm>
+            <a:off x="640080" y="457200"/>
+            <a:ext cx="10972800" cy="731520"/>
+          </a:xfrm>
+          <a:prstGeom prst="rect">
+            <a:avLst/>
+          </a:prstGeom>
+          <a:noFill/>
+        </p:spPr>
+        <p:txBody>
+          <a:bodyPr wrap="square">
+            <a:spAutoFit/>
+          </a:bodyPr>
+          <a:lstStyle/>
+          <a:p>
             <a:pPr algn="l">
-              <a:defRPr sz="1200" b="0">
-                <a:solidFill>
-                  <a:srgbClr val="6E6E73"/>
+              <a:defRPr sz="2600" b="1">
+                <a:solidFill>
+                  <a:srgbClr val="1D1D1F"/>
                 </a:solidFill>
               </a:defRPr>
             </a:pPr>
             <a:r>
-              <a:t>Integrate "100% Recycled Cobalt/Gold" and "Scope 3 Reduction" stats into B2B sales materials.</a:t>
-            </a:r>
-          </a:p>
-        </p:txBody>
-      </p:sp>
-      <p:sp>
-        <p:nvSpPr>
-          <p:cNvPr id="8" name="Rounded Rectangle 7"/>
+              <a:t>Leveraging FY25 Wins in the Market (Action Plan)</a:t>
+            </a:r>
+          </a:p>
+        </p:txBody>
+      </p:sp>
+      <p:sp>
+        <p:nvSpPr>
+          <p:cNvPr id="3" name="Rounded Rectangle 2"/>
           <p:cNvSpPr/>
           <p:nvPr/>
         </p:nvSpPr>
         <p:spPr>
           <a:xfrm>
-            <a:off x="4480560" y="1828800"/>
-            <a:ext cx="3474720" cy="3474720"/>
+            <a:off x="457200" y="1828800"/>
+            <a:ext cx="2651760" cy="3474720"/>
           </a:xfrm>
           <a:prstGeom prst="roundRect">
             <a:avLst/>
@@ -6657,13 +6929,13 @@
       </p:sp>
       <p:sp>
         <p:nvSpPr>
-          <p:cNvPr id="9" name="Oval 8"/>
+          <p:cNvPr id="4" name="Oval 3"/>
           <p:cNvSpPr/>
           <p:nvPr/>
         </p:nvSpPr>
         <p:spPr>
           <a:xfrm>
-            <a:off x="4754880" y="2103120"/>
+            <a:off x="731520" y="2103120"/>
             <a:ext cx="457200" cy="457200"/>
           </a:xfrm>
           <a:prstGeom prst="ellipse">
@@ -6700,13 +6972,13 @@
       </p:sp>
       <p:sp>
         <p:nvSpPr>
-          <p:cNvPr id="10" name="TextBox 9"/>
+          <p:cNvPr id="5" name="TextBox 4"/>
           <p:cNvSpPr txBox="1"/>
           <p:nvPr/>
         </p:nvSpPr>
         <p:spPr>
           <a:xfrm>
-            <a:off x="4754880" y="2148840"/>
+            <a:off x="731520" y="2148840"/>
             <a:ext cx="457200" cy="365760"/>
           </a:xfrm>
           <a:prstGeom prst="rect">
@@ -6728,21 +7000,21 @@
               </a:defRPr>
             </a:pPr>
             <a:r>
-              <a:t>2</a:t>
-            </a:r>
-          </a:p>
-        </p:txBody>
-      </p:sp>
-      <p:sp>
-        <p:nvSpPr>
-          <p:cNvPr id="11" name="TextBox 10"/>
+              <a:t>1</a:t>
+            </a:r>
+          </a:p>
+        </p:txBody>
+      </p:sp>
+      <p:sp>
+        <p:nvSpPr>
+          <p:cNvPr id="6" name="TextBox 5"/>
           <p:cNvSpPr txBox="1"/>
           <p:nvPr/>
         </p:nvSpPr>
         <p:spPr>
           <a:xfrm>
-            <a:off x="4754880" y="2743200"/>
-            <a:ext cx="2926080" cy="457200"/>
+            <a:off x="685800" y="2743200"/>
+            <a:ext cx="2194560" cy="457200"/>
           </a:xfrm>
           <a:prstGeom prst="rect">
             <a:avLst/>
@@ -6756,28 +7028,28 @@
           <a:lstStyle/>
           <a:p>
             <a:pPr algn="l">
-              <a:defRPr sz="1600" b="1">
+              <a:defRPr sz="1400" b="1">
                 <a:solidFill>
                   <a:srgbClr val="1D1D1F"/>
                 </a:solidFill>
               </a:defRPr>
             </a:pPr>
             <a:r>
-              <a:t>Retail Training</a:t>
-            </a:r>
-          </a:p>
-        </p:txBody>
-      </p:sp>
-      <p:sp>
-        <p:nvSpPr>
-          <p:cNvPr id="12" name="TextBox 11"/>
+              <a:t>Enterprise Pitch Decks</a:t>
+            </a:r>
+          </a:p>
+        </p:txBody>
+      </p:sp>
+      <p:sp>
+        <p:nvSpPr>
+          <p:cNvPr id="7" name="TextBox 6"/>
           <p:cNvSpPr txBox="1"/>
           <p:nvPr/>
         </p:nvSpPr>
         <p:spPr>
           <a:xfrm>
-            <a:off x="4754880" y="3291840"/>
-            <a:ext cx="2926080" cy="1371600"/>
+            <a:off x="685800" y="3291840"/>
+            <a:ext cx="2194560" cy="1645920"/>
           </a:xfrm>
           <a:prstGeom prst="rect">
             <a:avLst/>
@@ -6791,28 +7063,28 @@
           <a:lstStyle/>
           <a:p>
             <a:pPr algn="l">
-              <a:defRPr sz="1200" b="0">
+              <a:defRPr sz="1000" b="0">
                 <a:solidFill>
                   <a:srgbClr val="6E6E73"/>
                 </a:solidFill>
               </a:defRPr>
             </a:pPr>
             <a:r>
-              <a:t>Equip Apple Store teams with "17 Billion Gallons Saved" talking points for customer engagement.</a:t>
-            </a:r>
-          </a:p>
-        </p:txBody>
-      </p:sp>
-      <p:sp>
-        <p:nvSpPr>
-          <p:cNvPr id="13" name="Rounded Rectangle 12"/>
+              <a:t>Integrate "100% Recycled Cobalt/Gold" and "Scope 3 Reduction" stats into B2B sales materials.</a:t>
+            </a:r>
+          </a:p>
+        </p:txBody>
+      </p:sp>
+      <p:sp>
+        <p:nvSpPr>
+          <p:cNvPr id="8" name="Rounded Rectangle 7"/>
           <p:cNvSpPr/>
           <p:nvPr/>
         </p:nvSpPr>
         <p:spPr>
           <a:xfrm>
-            <a:off x="8321040" y="1828800"/>
-            <a:ext cx="3474720" cy="3474720"/>
+            <a:off x="3337560" y="1828800"/>
+            <a:ext cx="2651760" cy="3474720"/>
           </a:xfrm>
           <a:prstGeom prst="roundRect">
             <a:avLst/>
@@ -6848,13 +7120,13 @@
       </p:sp>
       <p:sp>
         <p:nvSpPr>
-          <p:cNvPr id="14" name="Oval 13"/>
+          <p:cNvPr id="9" name="Oval 8"/>
           <p:cNvSpPr/>
           <p:nvPr/>
         </p:nvSpPr>
         <p:spPr>
           <a:xfrm>
-            <a:off x="8595360" y="2103120"/>
+            <a:off x="3611879" y="2103120"/>
             <a:ext cx="457200" cy="457200"/>
           </a:xfrm>
           <a:prstGeom prst="ellipse">
@@ -6891,13 +7163,13 @@
       </p:sp>
       <p:sp>
         <p:nvSpPr>
-          <p:cNvPr id="15" name="TextBox 14"/>
+          <p:cNvPr id="10" name="TextBox 9"/>
           <p:cNvSpPr txBox="1"/>
           <p:nvPr/>
         </p:nvSpPr>
         <p:spPr>
           <a:xfrm>
-            <a:off x="8595360" y="2148840"/>
+            <a:off x="3611879" y="2148840"/>
             <a:ext cx="457200" cy="365760"/>
           </a:xfrm>
           <a:prstGeom prst="rect">
@@ -6919,21 +7191,21 @@
               </a:defRPr>
             </a:pPr>
             <a:r>
-              <a:t>3</a:t>
-            </a:r>
-          </a:p>
-        </p:txBody>
-      </p:sp>
-      <p:sp>
-        <p:nvSpPr>
-          <p:cNvPr id="16" name="TextBox 15"/>
+              <a:t>2</a:t>
+            </a:r>
+          </a:p>
+        </p:txBody>
+      </p:sp>
+      <p:sp>
+        <p:nvSpPr>
+          <p:cNvPr id="11" name="TextBox 10"/>
           <p:cNvSpPr txBox="1"/>
           <p:nvPr/>
         </p:nvSpPr>
         <p:spPr>
           <a:xfrm>
-            <a:off x="8595360" y="2743200"/>
-            <a:ext cx="2926080" cy="457200"/>
+            <a:off x="3566160" y="2743200"/>
+            <a:ext cx="2194560" cy="457200"/>
           </a:xfrm>
           <a:prstGeom prst="rect">
             <a:avLst/>
@@ -6947,28 +7219,28 @@
           <a:lstStyle/>
           <a:p>
             <a:pPr algn="l">
-              <a:defRPr sz="1600" b="1">
+              <a:defRPr sz="1400" b="1">
                 <a:solidFill>
                   <a:srgbClr val="1D1D1F"/>
                 </a:solidFill>
               </a:defRPr>
             </a:pPr>
             <a:r>
-              <a:t>Marketing</a:t>
-            </a:r>
-          </a:p>
-        </p:txBody>
-      </p:sp>
-      <p:sp>
-        <p:nvSpPr>
-          <p:cNvPr id="17" name="TextBox 16"/>
+              <a:t>Retail Training</a:t>
+            </a:r>
+          </a:p>
+        </p:txBody>
+      </p:sp>
+      <p:sp>
+        <p:nvSpPr>
+          <p:cNvPr id="12" name="TextBox 11"/>
           <p:cNvSpPr txBox="1"/>
           <p:nvPr/>
         </p:nvSpPr>
         <p:spPr>
           <a:xfrm>
-            <a:off x="8595360" y="3291840"/>
-            <a:ext cx="2926080" cy="1371600"/>
+            <a:off x="3566160" y="3291840"/>
+            <a:ext cx="2194560" cy="1645920"/>
           </a:xfrm>
           <a:prstGeom prst="rect">
             <a:avLst/>
@@ -6982,14 +7254,396 @@
           <a:lstStyle/>
           <a:p>
             <a:pPr algn="l">
-              <a:defRPr sz="1200" b="0">
+              <a:defRPr sz="1000" b="0">
                 <a:solidFill>
                   <a:srgbClr val="6E6E73"/>
                 </a:solidFill>
               </a:defRPr>
             </a:pPr>
             <a:r>
+              <a:t>Equip Apple Store teams with "17 Billion Gallons Saved" talking points for customer engagement.</a:t>
+            </a:r>
+          </a:p>
+        </p:txBody>
+      </p:sp>
+      <p:sp>
+        <p:nvSpPr>
+          <p:cNvPr id="13" name="Rounded Rectangle 12"/>
+          <p:cNvSpPr/>
+          <p:nvPr/>
+        </p:nvSpPr>
+        <p:spPr>
+          <a:xfrm>
+            <a:off x="6217920" y="1828800"/>
+            <a:ext cx="2651760" cy="3474720"/>
+          </a:xfrm>
+          <a:prstGeom prst="roundRect">
+            <a:avLst/>
+          </a:prstGeom>
+          <a:solidFill>
+            <a:srgbClr val="F5F5F7"/>
+          </a:solidFill>
+          <a:ln>
+            <a:noFill/>
+          </a:ln>
+        </p:spPr>
+        <p:style>
+          <a:lnRef idx="1">
+            <a:schemeClr val="accent1"/>
+          </a:lnRef>
+          <a:fillRef idx="3">
+            <a:schemeClr val="accent1"/>
+          </a:fillRef>
+          <a:effectRef idx="2">
+            <a:schemeClr val="accent1"/>
+          </a:effectRef>
+          <a:fontRef idx="minor">
+            <a:schemeClr val="lt1"/>
+          </a:fontRef>
+        </p:style>
+        <p:txBody>
+          <a:bodyPr rtlCol="0" anchor="ctr"/>
+          <a:lstStyle/>
+          <a:p>
+            <a:pPr algn="ctr"/>
+          </a:p>
+        </p:txBody>
+      </p:sp>
+      <p:sp>
+        <p:nvSpPr>
+          <p:cNvPr id="14" name="Oval 13"/>
+          <p:cNvSpPr/>
+          <p:nvPr/>
+        </p:nvSpPr>
+        <p:spPr>
+          <a:xfrm>
+            <a:off x="6492240" y="2103120"/>
+            <a:ext cx="457200" cy="457200"/>
+          </a:xfrm>
+          <a:prstGeom prst="ellipse">
+            <a:avLst/>
+          </a:prstGeom>
+          <a:solidFill>
+            <a:srgbClr val="1A7F37"/>
+          </a:solidFill>
+          <a:ln>
+            <a:noFill/>
+          </a:ln>
+        </p:spPr>
+        <p:style>
+          <a:lnRef idx="1">
+            <a:schemeClr val="accent1"/>
+          </a:lnRef>
+          <a:fillRef idx="3">
+            <a:schemeClr val="accent1"/>
+          </a:fillRef>
+          <a:effectRef idx="2">
+            <a:schemeClr val="accent1"/>
+          </a:effectRef>
+          <a:fontRef idx="minor">
+            <a:schemeClr val="lt1"/>
+          </a:fontRef>
+        </p:style>
+        <p:txBody>
+          <a:bodyPr rtlCol="0" anchor="ctr"/>
+          <a:lstStyle/>
+          <a:p>
+            <a:pPr algn="ctr"/>
+          </a:p>
+        </p:txBody>
+      </p:sp>
+      <p:sp>
+        <p:nvSpPr>
+          <p:cNvPr id="15" name="TextBox 14"/>
+          <p:cNvSpPr txBox="1"/>
+          <p:nvPr/>
+        </p:nvSpPr>
+        <p:spPr>
+          <a:xfrm>
+            <a:off x="6492240" y="2148840"/>
+            <a:ext cx="457200" cy="365760"/>
+          </a:xfrm>
+          <a:prstGeom prst="rect">
+            <a:avLst/>
+          </a:prstGeom>
+          <a:noFill/>
+        </p:spPr>
+        <p:txBody>
+          <a:bodyPr wrap="square">
+            <a:spAutoFit/>
+          </a:bodyPr>
+          <a:lstStyle/>
+          <a:p>
+            <a:pPr algn="ctr">
+              <a:defRPr sz="1400" b="1">
+                <a:solidFill>
+                  <a:srgbClr val="FFFFFF"/>
+                </a:solidFill>
+              </a:defRPr>
+            </a:pPr>
+            <a:r>
+              <a:t>3</a:t>
+            </a:r>
+          </a:p>
+        </p:txBody>
+      </p:sp>
+      <p:sp>
+        <p:nvSpPr>
+          <p:cNvPr id="16" name="TextBox 15"/>
+          <p:cNvSpPr txBox="1"/>
+          <p:nvPr/>
+        </p:nvSpPr>
+        <p:spPr>
+          <a:xfrm>
+            <a:off x="6446520" y="2743200"/>
+            <a:ext cx="2194560" cy="457200"/>
+          </a:xfrm>
+          <a:prstGeom prst="rect">
+            <a:avLst/>
+          </a:prstGeom>
+          <a:noFill/>
+        </p:spPr>
+        <p:txBody>
+          <a:bodyPr wrap="square">
+            <a:spAutoFit/>
+          </a:bodyPr>
+          <a:lstStyle/>
+          <a:p>
+            <a:pPr algn="l">
+              <a:defRPr sz="1400" b="1">
+                <a:solidFill>
+                  <a:srgbClr val="1D1D1F"/>
+                </a:solidFill>
+              </a:defRPr>
+            </a:pPr>
+            <a:r>
+              <a:t>Marketing</a:t>
+            </a:r>
+          </a:p>
+        </p:txBody>
+      </p:sp>
+      <p:sp>
+        <p:nvSpPr>
+          <p:cNvPr id="17" name="TextBox 16"/>
+          <p:cNvSpPr txBox="1"/>
+          <p:nvPr/>
+        </p:nvSpPr>
+        <p:spPr>
+          <a:xfrm>
+            <a:off x="6446520" y="3291840"/>
+            <a:ext cx="2194560" cy="1645920"/>
+          </a:xfrm>
+          <a:prstGeom prst="rect">
+            <a:avLst/>
+          </a:prstGeom>
+          <a:noFill/>
+        </p:spPr>
+        <p:txBody>
+          <a:bodyPr wrap="square">
+            <a:spAutoFit/>
+          </a:bodyPr>
+          <a:lstStyle/>
+          <a:p>
+            <a:pPr algn="l">
+              <a:defRPr sz="1000" b="0">
+                <a:solidFill>
+                  <a:srgbClr val="6E6E73"/>
+                </a:solidFill>
+              </a:defRPr>
+            </a:pPr>
+            <a:r>
               <a:t>Launch a campaign highlighting the 100% plastic-free unboxing experience as a premium feature.</a:t>
+            </a:r>
+          </a:p>
+        </p:txBody>
+      </p:sp>
+      <p:sp>
+        <p:nvSpPr>
+          <p:cNvPr id="18" name="Rounded Rectangle 17"/>
+          <p:cNvSpPr/>
+          <p:nvPr/>
+        </p:nvSpPr>
+        <p:spPr>
+          <a:xfrm>
+            <a:off x="9098280" y="1828800"/>
+            <a:ext cx="2651760" cy="3474720"/>
+          </a:xfrm>
+          <a:prstGeom prst="roundRect">
+            <a:avLst/>
+          </a:prstGeom>
+          <a:solidFill>
+            <a:srgbClr val="F5F5F7"/>
+          </a:solidFill>
+          <a:ln>
+            <a:noFill/>
+          </a:ln>
+        </p:spPr>
+        <p:style>
+          <a:lnRef idx="1">
+            <a:schemeClr val="accent1"/>
+          </a:lnRef>
+          <a:fillRef idx="3">
+            <a:schemeClr val="accent1"/>
+          </a:fillRef>
+          <a:effectRef idx="2">
+            <a:schemeClr val="accent1"/>
+          </a:effectRef>
+          <a:fontRef idx="minor">
+            <a:schemeClr val="lt1"/>
+          </a:fontRef>
+        </p:style>
+        <p:txBody>
+          <a:bodyPr rtlCol="0" anchor="ctr"/>
+          <a:lstStyle/>
+          <a:p>
+            <a:pPr algn="ctr"/>
+          </a:p>
+        </p:txBody>
+      </p:sp>
+      <p:sp>
+        <p:nvSpPr>
+          <p:cNvPr id="19" name="Oval 18"/>
+          <p:cNvSpPr/>
+          <p:nvPr/>
+        </p:nvSpPr>
+        <p:spPr>
+          <a:xfrm>
+            <a:off x="9372600" y="2103120"/>
+            <a:ext cx="457200" cy="457200"/>
+          </a:xfrm>
+          <a:prstGeom prst="ellipse">
+            <a:avLst/>
+          </a:prstGeom>
+          <a:solidFill>
+            <a:srgbClr val="1A7F37"/>
+          </a:solidFill>
+          <a:ln>
+            <a:noFill/>
+          </a:ln>
+        </p:spPr>
+        <p:style>
+          <a:lnRef idx="1">
+            <a:schemeClr val="accent1"/>
+          </a:lnRef>
+          <a:fillRef idx="3">
+            <a:schemeClr val="accent1"/>
+          </a:fillRef>
+          <a:effectRef idx="2">
+            <a:schemeClr val="accent1"/>
+          </a:effectRef>
+          <a:fontRef idx="minor">
+            <a:schemeClr val="lt1"/>
+          </a:fontRef>
+        </p:style>
+        <p:txBody>
+          <a:bodyPr rtlCol="0" anchor="ctr"/>
+          <a:lstStyle/>
+          <a:p>
+            <a:pPr algn="ctr"/>
+          </a:p>
+        </p:txBody>
+      </p:sp>
+      <p:sp>
+        <p:nvSpPr>
+          <p:cNvPr id="20" name="TextBox 19"/>
+          <p:cNvSpPr txBox="1"/>
+          <p:nvPr/>
+        </p:nvSpPr>
+        <p:spPr>
+          <a:xfrm>
+            <a:off x="9372600" y="2148840"/>
+            <a:ext cx="457200" cy="365760"/>
+          </a:xfrm>
+          <a:prstGeom prst="rect">
+            <a:avLst/>
+          </a:prstGeom>
+          <a:noFill/>
+        </p:spPr>
+        <p:txBody>
+          <a:bodyPr wrap="square">
+            <a:spAutoFit/>
+          </a:bodyPr>
+          <a:lstStyle/>
+          <a:p>
+            <a:pPr algn="ctr">
+              <a:defRPr sz="1400" b="1">
+                <a:solidFill>
+                  <a:srgbClr val="FFFFFF"/>
+                </a:solidFill>
+              </a:defRPr>
+            </a:pPr>
+            <a:r>
+              <a:t>4</a:t>
+            </a:r>
+          </a:p>
+        </p:txBody>
+      </p:sp>
+      <p:sp>
+        <p:nvSpPr>
+          <p:cNvPr id="21" name="TextBox 20"/>
+          <p:cNvSpPr txBox="1"/>
+          <p:nvPr/>
+        </p:nvSpPr>
+        <p:spPr>
+          <a:xfrm>
+            <a:off x="9326880" y="2743200"/>
+            <a:ext cx="2194560" cy="457200"/>
+          </a:xfrm>
+          <a:prstGeom prst="rect">
+            <a:avLst/>
+          </a:prstGeom>
+          <a:noFill/>
+        </p:spPr>
+        <p:txBody>
+          <a:bodyPr wrap="square">
+            <a:spAutoFit/>
+          </a:bodyPr>
+          <a:lstStyle/>
+          <a:p>
+            <a:pPr algn="l">
+              <a:defRPr sz="1400" b="1">
+                <a:solidFill>
+                  <a:srgbClr val="1D1D1F"/>
+                </a:solidFill>
+              </a:defRPr>
+            </a:pPr>
+            <a:r>
+              <a:t>Merchant Services</a:t>
+            </a:r>
+          </a:p>
+        </p:txBody>
+      </p:sp>
+      <p:sp>
+        <p:nvSpPr>
+          <p:cNvPr id="22" name="TextBox 21"/>
+          <p:cNvSpPr txBox="1"/>
+          <p:nvPr/>
+        </p:nvSpPr>
+        <p:spPr>
+          <a:xfrm>
+            <a:off x="9326880" y="3291840"/>
+            <a:ext cx="2194560" cy="1645920"/>
+          </a:xfrm>
+          <a:prstGeom prst="rect">
+            <a:avLst/>
+          </a:prstGeom>
+          <a:noFill/>
+        </p:spPr>
+        <p:txBody>
+          <a:bodyPr wrap="square">
+            <a:spAutoFit/>
+          </a:bodyPr>
+          <a:lstStyle/>
+          <a:p>
+            <a:pPr algn="l">
+              <a:defRPr sz="1000" b="0">
+                <a:solidFill>
+                  <a:srgbClr val="6E6E73"/>
+                </a:solidFill>
+              </a:defRPr>
+            </a:pPr>
+            <a:r>
+              <a:t>Onboard sellers to Tap to Pay on iPhone Air — apple.com/shop/buy-iphone/iphone-air</a:t>
             </a:r>
           </a:p>
         </p:txBody>

</xml_diff>

<commit_message>
Add Apple FY2025 Environmental Progress board presentation deck (#78)
</commit_message>
<xml_diff>
--- a/presentations/apple-fy2025-environmental/Apple_FY2025_Environmental_Progress.pptx
+++ b/presentations/apple-fy2025-environmental/Apple_FY2025_Environmental_Progress.pptx
@@ -13,6 +13,7 @@
     <p:sldId id="261" r:id="rId13"/>
     <p:sldId id="262" r:id="rId14"/>
     <p:sldId id="263" r:id="rId15"/>
+    <p:sldId id="264" r:id="rId16"/>
   </p:sldIdLst>
   <p:sldSz cx="12191695" cy="6858000" type="screen4x3"/>
   <p:notesSz cx="6858000" cy="9144000"/>
@@ -955,6 +956,76 @@
 </file>
 
 <file path=ppt/notesSlides/notesSlide8.xml><?xml version="1.0" encoding="utf-8"?>
+<p:notes xmlns:a="http://schemas.openxmlformats.org/drawingml/2006/main" xmlns:p="http://schemas.openxmlformats.org/presentationml/2006/main" xmlns:r="http://schemas.openxmlformats.org/officeDocument/2006/relationships">
+  <p:cSld>
+    <p:spTree>
+      <p:nvGrpSpPr>
+        <p:cNvPr id="1" name=""/>
+        <p:cNvGrpSpPr/>
+        <p:nvPr/>
+      </p:nvGrpSpPr>
+      <p:grpSpPr>
+        <a:xfrm>
+          <a:off x="0" y="0"/>
+          <a:ext cx="0" cy="0"/>
+          <a:chOff x="0" y="0"/>
+          <a:chExt cx="0" cy="0"/>
+        </a:xfrm>
+      </p:grpSpPr>
+      <p:sp>
+        <p:nvSpPr>
+          <p:cNvPr id="2" name="Slide Image Placeholder 1"/>
+          <p:cNvSpPr>
+            <a:spLocks noGrp="1"/>
+          </p:cNvSpPr>
+          <p:nvPr>
+            <p:ph type="sldImg" idx="2"/>
+          </p:nvPr>
+        </p:nvSpPr>
+        <p:spPr/>
+      </p:sp>
+      <p:sp>
+        <p:nvSpPr>
+          <p:cNvPr id="3" name="Notes Placeholder 2"/>
+          <p:cNvSpPr>
+            <a:spLocks noGrp="1"/>
+          </p:cNvSpPr>
+          <p:nvPr>
+            <p:ph type="body" idx="3" sz="quarter"/>
+          </p:nvPr>
+        </p:nvSpPr>
+        <p:spPr/>
+        <p:txBody>
+          <a:bodyPr/>
+          <a:lstStyle/>
+          <a:p>
+            <a:r>
+              <a:t>Merchant Services extends our environmental and premium-brand story into the seller ecosystem. iPhone Air enables Tap to Pay on iPhone — sellers accept Apple Pay and contactless cards with no additional hardware. Direct sellers to apple.com/shop/buy-iphone/iphone-air for fleet upgrades.</a:t>
+            </a:r>
+          </a:p>
+        </p:txBody>
+      </p:sp>
+      <p:sp>
+        <p:nvSpPr>
+          <p:cNvPr id="4" name="Slide Number Placeholder 3"/>
+          <p:cNvSpPr>
+            <a:spLocks noGrp="1"/>
+          </p:cNvSpPr>
+          <p:nvPr>
+            <p:ph type="sldNum" idx="5" sz="quarter"/>
+          </p:nvPr>
+        </p:nvSpPr>
+        <p:spPr/>
+      </p:sp>
+    </p:spTree>
+  </p:cSld>
+  <p:clrMapOvr>
+    <a:masterClrMapping/>
+  </p:clrMapOvr>
+</p:notes>
+</file>
+
+<file path=ppt/notesSlides/notesSlide9.xml><?xml version="1.0" encoding="utf-8"?>
 <p:notes xmlns:a="http://schemas.openxmlformats.org/drawingml/2006/main" xmlns:p="http://schemas.openxmlformats.org/presentationml/2006/main" xmlns:r="http://schemas.openxmlformats.org/officeDocument/2006/relationships">
   <p:cSld>
     <p:spTree>
@@ -6395,7 +6466,7 @@
         <p:spPr>
           <a:xfrm>
             <a:off x="640080" y="457200"/>
-            <a:ext cx="10972800" cy="731520"/>
+            <a:ext cx="5486400" cy="914400"/>
           </a:xfrm>
           <a:prstGeom prst="rect">
             <a:avLst/>
@@ -6409,34 +6480,174 @@
           <a:lstStyle/>
           <a:p>
             <a:pPr algn="l">
-              <a:defRPr sz="2600" b="1">
+              <a:defRPr sz="2400" b="1">
                 <a:solidFill>
                   <a:srgbClr val="1D1D1F"/>
                 </a:solidFill>
               </a:defRPr>
             </a:pPr>
             <a:r>
-              <a:t>Leveraging FY25 Wins in the Market (Action Plan)</a:t>
-            </a:r>
-          </a:p>
-        </p:txBody>
-      </p:sp>
-      <p:sp>
-        <p:nvSpPr>
-          <p:cNvPr id="3" name="Rounded Rectangle 2"/>
+              <a:t>Merchant Services: Empowering Sellers with iPhone Air</a:t>
+            </a:r>
+          </a:p>
+        </p:txBody>
+      </p:sp>
+      <p:sp>
+        <p:nvSpPr>
+          <p:cNvPr id="3" name="TextBox 2"/>
+          <p:cNvSpPr txBox="1"/>
+          <p:nvPr/>
+        </p:nvSpPr>
+        <p:spPr>
+          <a:xfrm>
+            <a:off x="822960" y="1645920"/>
+            <a:ext cx="5303520" cy="640080"/>
+          </a:xfrm>
+          <a:prstGeom prst="rect">
+            <a:avLst/>
+          </a:prstGeom>
+          <a:noFill/>
+        </p:spPr>
+        <p:txBody>
+          <a:bodyPr wrap="square">
+            <a:spAutoFit/>
+          </a:bodyPr>
+          <a:lstStyle/>
+          <a:p>
+            <a:pPr algn="l">
+              <a:defRPr sz="1400" b="0">
+                <a:solidFill>
+                  <a:srgbClr val="1D1D1F"/>
+                </a:solidFill>
+              </a:defRPr>
+            </a:pPr>
+            <a:r>
+              <a:t>•  Tap to Pay on iPhone: Accept contactless payments with no extra hardware.</a:t>
+            </a:r>
+          </a:p>
+        </p:txBody>
+      </p:sp>
+      <p:sp>
+        <p:nvSpPr>
+          <p:cNvPr id="4" name="TextBox 3"/>
+          <p:cNvSpPr txBox="1"/>
+          <p:nvPr/>
+        </p:nvSpPr>
+        <p:spPr>
+          <a:xfrm>
+            <a:off x="822960" y="2331720"/>
+            <a:ext cx="5303520" cy="640080"/>
+          </a:xfrm>
+          <a:prstGeom prst="rect">
+            <a:avLst/>
+          </a:prstGeom>
+          <a:noFill/>
+        </p:spPr>
+        <p:txBody>
+          <a:bodyPr wrap="square">
+            <a:spAutoFit/>
+          </a:bodyPr>
+          <a:lstStyle/>
+          <a:p>
+            <a:pPr algn="l">
+              <a:defRPr sz="1400" b="0">
+                <a:solidFill>
+                  <a:srgbClr val="1D1D1F"/>
+                </a:solidFill>
+              </a:defRPr>
+            </a:pPr>
+            <a:r>
+              <a:t>•  Apple Pay for Business: Faster checkout and higher conversion.</a:t>
+            </a:r>
+          </a:p>
+        </p:txBody>
+      </p:sp>
+      <p:sp>
+        <p:nvSpPr>
+          <p:cNvPr id="5" name="TextBox 4"/>
+          <p:cNvSpPr txBox="1"/>
+          <p:nvPr/>
+        </p:nvSpPr>
+        <p:spPr>
+          <a:xfrm>
+            <a:off x="822960" y="3017520"/>
+            <a:ext cx="5303520" cy="640080"/>
+          </a:xfrm>
+          <a:prstGeom prst="rect">
+            <a:avLst/>
+          </a:prstGeom>
+          <a:noFill/>
+        </p:spPr>
+        <p:txBody>
+          <a:bodyPr wrap="square">
+            <a:spAutoFit/>
+          </a:bodyPr>
+          <a:lstStyle/>
+          <a:p>
+            <a:pPr algn="l">
+              <a:defRPr sz="1400" b="0">
+                <a:solidFill>
+                  <a:srgbClr val="1D1D1F"/>
+                </a:solidFill>
+              </a:defRPr>
+            </a:pPr>
+            <a:r>
+              <a:t>•  Seller Upgrade Path: Equip partners with iPhone Air from $999.</a:t>
+            </a:r>
+          </a:p>
+        </p:txBody>
+      </p:sp>
+      <p:sp>
+        <p:nvSpPr>
+          <p:cNvPr id="6" name="TextBox 5"/>
+          <p:cNvSpPr txBox="1"/>
+          <p:nvPr/>
+        </p:nvSpPr>
+        <p:spPr>
+          <a:xfrm>
+            <a:off x="822960" y="3840480"/>
+            <a:ext cx="5029200" cy="365760"/>
+          </a:xfrm>
+          <a:prstGeom prst="rect">
+            <a:avLst/>
+          </a:prstGeom>
+          <a:noFill/>
+        </p:spPr>
+        <p:txBody>
+          <a:bodyPr wrap="square">
+            <a:spAutoFit/>
+          </a:bodyPr>
+          <a:lstStyle/>
+          <a:p>
+            <a:pPr algn="l">
+              <a:defRPr sz="1200" b="1">
+                <a:solidFill>
+                  <a:srgbClr val="1A7F37"/>
+                </a:solidFill>
+              </a:defRPr>
+            </a:pPr>
+            <a:r>
+              <a:t>apple.com/shop/buy-iphone/iphone-air</a:t>
+            </a:r>
+          </a:p>
+        </p:txBody>
+      </p:sp>
+      <p:sp>
+        <p:nvSpPr>
+          <p:cNvPr id="7" name="Rounded Rectangle 6"/>
           <p:cNvSpPr/>
           <p:nvPr/>
         </p:nvSpPr>
         <p:spPr>
           <a:xfrm>
-            <a:off x="640080" y="1828800"/>
-            <a:ext cx="3474720" cy="3474720"/>
+            <a:off x="7772400" y="1371600"/>
+            <a:ext cx="2011680" cy="3840480"/>
           </a:xfrm>
           <a:prstGeom prst="roundRect">
             <a:avLst/>
           </a:prstGeom>
           <a:solidFill>
-            <a:srgbClr val="F5F5F7"/>
+            <a:srgbClr val="1D1D1F"/>
           </a:solidFill>
           <a:ln>
             <a:noFill/>
@@ -6466,20 +6677,20 @@
       </p:sp>
       <p:sp>
         <p:nvSpPr>
-          <p:cNvPr id="4" name="Oval 3"/>
+          <p:cNvPr id="8" name="Rounded Rectangle 7"/>
           <p:cNvSpPr/>
           <p:nvPr/>
         </p:nvSpPr>
         <p:spPr>
           <a:xfrm>
-            <a:off x="914400" y="2103120"/>
-            <a:ext cx="457200" cy="457200"/>
-          </a:xfrm>
-          <a:prstGeom prst="ellipse">
+            <a:off x="7955279" y="1645920"/>
+            <a:ext cx="1645920" cy="3108960"/>
+          </a:xfrm>
+          <a:prstGeom prst="roundRect">
             <a:avLst/>
           </a:prstGeom>
           <a:solidFill>
-            <a:srgbClr val="1A7F37"/>
+            <a:srgbClr val="F5F5F7"/>
           </a:solidFill>
           <a:ln>
             <a:noFill/>
@@ -6509,14 +6720,14 @@
       </p:sp>
       <p:sp>
         <p:nvSpPr>
-          <p:cNvPr id="5" name="TextBox 4"/>
+          <p:cNvPr id="9" name="TextBox 8"/>
           <p:cNvSpPr txBox="1"/>
           <p:nvPr/>
         </p:nvSpPr>
         <p:spPr>
           <a:xfrm>
-            <a:off x="914400" y="2148840"/>
-            <a:ext cx="457200" cy="365760"/>
+            <a:off x="7955279" y="2560320"/>
+            <a:ext cx="1645920" cy="365760"/>
           </a:xfrm>
           <a:prstGeom prst="rect">
             <a:avLst/>
@@ -6530,28 +6741,28 @@
           <a:lstStyle/>
           <a:p>
             <a:pPr algn="ctr">
-              <a:defRPr sz="1400" b="1">
-                <a:solidFill>
-                  <a:srgbClr val="FFFFFF"/>
+              <a:defRPr sz="1100" b="1">
+                <a:solidFill>
+                  <a:srgbClr val="1D1D1F"/>
                 </a:solidFill>
               </a:defRPr>
             </a:pPr>
             <a:r>
-              <a:t>1</a:t>
-            </a:r>
-          </a:p>
-        </p:txBody>
-      </p:sp>
-      <p:sp>
-        <p:nvSpPr>
-          <p:cNvPr id="6" name="TextBox 5"/>
+              <a:t>Tap to Pay</a:t>
+            </a:r>
+          </a:p>
+        </p:txBody>
+      </p:sp>
+      <p:sp>
+        <p:nvSpPr>
+          <p:cNvPr id="10" name="TextBox 9"/>
           <p:cNvSpPr txBox="1"/>
           <p:nvPr/>
         </p:nvSpPr>
         <p:spPr>
           <a:xfrm>
-            <a:off x="914400" y="2743200"/>
-            <a:ext cx="2926080" cy="457200"/>
+            <a:off x="7955279" y="2926080"/>
+            <a:ext cx="1645920" cy="457200"/>
           </a:xfrm>
           <a:prstGeom prst="rect">
             <a:avLst/>
@@ -6564,29 +6775,29 @@
           </a:bodyPr>
           <a:lstStyle/>
           <a:p>
-            <a:pPr algn="l">
+            <a:pPr algn="ctr">
               <a:defRPr sz="1600" b="1">
                 <a:solidFill>
-                  <a:srgbClr val="1D1D1F"/>
+                  <a:srgbClr val="1A7F37"/>
                 </a:solidFill>
               </a:defRPr>
             </a:pPr>
             <a:r>
-              <a:t>Enterprise Pitch Decks</a:t>
-            </a:r>
-          </a:p>
-        </p:txBody>
-      </p:sp>
-      <p:sp>
-        <p:nvSpPr>
-          <p:cNvPr id="7" name="TextBox 6"/>
+              <a:t>$999.00</a:t>
+            </a:r>
+          </a:p>
+        </p:txBody>
+      </p:sp>
+      <p:sp>
+        <p:nvSpPr>
+          <p:cNvPr id="11" name="TextBox 10"/>
           <p:cNvSpPr txBox="1"/>
           <p:nvPr/>
         </p:nvSpPr>
         <p:spPr>
           <a:xfrm>
-            <a:off x="914400" y="3291840"/>
-            <a:ext cx="2926080" cy="1371600"/>
+            <a:off x="7132320" y="5486400"/>
+            <a:ext cx="3474720" cy="457200"/>
           </a:xfrm>
           <a:prstGeom prst="rect">
             <a:avLst/>
@@ -6599,29 +6810,90 @@
           </a:bodyPr>
           <a:lstStyle/>
           <a:p>
+            <a:pPr algn="ctr">
+              <a:defRPr sz="1000" b="0">
+                <a:solidFill>
+                  <a:srgbClr val="6E6E73"/>
+                </a:solidFill>
+              </a:defRPr>
+            </a:pPr>
+            <a:r>
+              <a:t>The thinnest iPhone ever — now your sellers' point of sale.</a:t>
+            </a:r>
+          </a:p>
+        </p:txBody>
+      </p:sp>
+    </p:spTree>
+  </p:cSld>
+  <p:clrMapOvr>
+    <a:masterClrMapping/>
+  </p:clrMapOvr>
+</p:sld>
+</file>
+
+<file path=ppt/slides/slide9.xml><?xml version="1.0" encoding="utf-8"?>
+<p:sld xmlns:a="http://schemas.openxmlformats.org/drawingml/2006/main" xmlns:p="http://schemas.openxmlformats.org/presentationml/2006/main" xmlns:r="http://schemas.openxmlformats.org/officeDocument/2006/relationships">
+  <p:cSld>
+    <p:bg>
+      <p:bgPr>
+        <a:solidFill>
+          <a:srgbClr val="FFFFFF"/>
+        </a:solidFill>
+        <a:effectLst/>
+      </p:bgPr>
+    </p:bg>
+    <p:spTree>
+      <p:nvGrpSpPr>
+        <p:cNvPr id="1" name=""/>
+        <p:cNvGrpSpPr/>
+        <p:nvPr/>
+      </p:nvGrpSpPr>
+      <p:grpSpPr/>
+      <p:sp>
+        <p:nvSpPr>
+          <p:cNvPr id="2" name="TextBox 1"/>
+          <p:cNvSpPr txBox="1"/>
+          <p:nvPr/>
+        </p:nvSpPr>
+        <p:spPr>
+          <a:xfrm>
+            <a:off x="640080" y="457200"/>
+            <a:ext cx="10972800" cy="731520"/>
+          </a:xfrm>
+          <a:prstGeom prst="rect">
+            <a:avLst/>
+          </a:prstGeom>
+          <a:noFill/>
+        </p:spPr>
+        <p:txBody>
+          <a:bodyPr wrap="square">
+            <a:spAutoFit/>
+          </a:bodyPr>
+          <a:lstStyle/>
+          <a:p>
             <a:pPr algn="l">
-              <a:defRPr sz="1200" b="0">
-                <a:solidFill>
-                  <a:srgbClr val="6E6E73"/>
+              <a:defRPr sz="2600" b="1">
+                <a:solidFill>
+                  <a:srgbClr val="1D1D1F"/>
                 </a:solidFill>
               </a:defRPr>
             </a:pPr>
             <a:r>
-              <a:t>Integrate "100% Recycled Cobalt/Gold" and "Scope 3 Reduction" stats into B2B sales materials.</a:t>
-            </a:r>
-          </a:p>
-        </p:txBody>
-      </p:sp>
-      <p:sp>
-        <p:nvSpPr>
-          <p:cNvPr id="8" name="Rounded Rectangle 7"/>
+              <a:t>Leveraging FY25 Wins in the Market (Action Plan)</a:t>
+            </a:r>
+          </a:p>
+        </p:txBody>
+      </p:sp>
+      <p:sp>
+        <p:nvSpPr>
+          <p:cNvPr id="3" name="Rounded Rectangle 2"/>
           <p:cNvSpPr/>
           <p:nvPr/>
         </p:nvSpPr>
         <p:spPr>
           <a:xfrm>
-            <a:off x="4480560" y="1828800"/>
-            <a:ext cx="3474720" cy="3474720"/>
+            <a:off x="457200" y="1828800"/>
+            <a:ext cx="2651760" cy="3474720"/>
           </a:xfrm>
           <a:prstGeom prst="roundRect">
             <a:avLst/>
@@ -6657,13 +6929,13 @@
       </p:sp>
       <p:sp>
         <p:nvSpPr>
-          <p:cNvPr id="9" name="Oval 8"/>
+          <p:cNvPr id="4" name="Oval 3"/>
           <p:cNvSpPr/>
           <p:nvPr/>
         </p:nvSpPr>
         <p:spPr>
           <a:xfrm>
-            <a:off x="4754880" y="2103120"/>
+            <a:off x="731520" y="2103120"/>
             <a:ext cx="457200" cy="457200"/>
           </a:xfrm>
           <a:prstGeom prst="ellipse">
@@ -6700,13 +6972,13 @@
       </p:sp>
       <p:sp>
         <p:nvSpPr>
-          <p:cNvPr id="10" name="TextBox 9"/>
+          <p:cNvPr id="5" name="TextBox 4"/>
           <p:cNvSpPr txBox="1"/>
           <p:nvPr/>
         </p:nvSpPr>
         <p:spPr>
           <a:xfrm>
-            <a:off x="4754880" y="2148840"/>
+            <a:off x="731520" y="2148840"/>
             <a:ext cx="457200" cy="365760"/>
           </a:xfrm>
           <a:prstGeom prst="rect">
@@ -6728,21 +7000,21 @@
               </a:defRPr>
             </a:pPr>
             <a:r>
-              <a:t>2</a:t>
-            </a:r>
-          </a:p>
-        </p:txBody>
-      </p:sp>
-      <p:sp>
-        <p:nvSpPr>
-          <p:cNvPr id="11" name="TextBox 10"/>
+              <a:t>1</a:t>
+            </a:r>
+          </a:p>
+        </p:txBody>
+      </p:sp>
+      <p:sp>
+        <p:nvSpPr>
+          <p:cNvPr id="6" name="TextBox 5"/>
           <p:cNvSpPr txBox="1"/>
           <p:nvPr/>
         </p:nvSpPr>
         <p:spPr>
           <a:xfrm>
-            <a:off x="4754880" y="2743200"/>
-            <a:ext cx="2926080" cy="457200"/>
+            <a:off x="685800" y="2743200"/>
+            <a:ext cx="2194560" cy="457200"/>
           </a:xfrm>
           <a:prstGeom prst="rect">
             <a:avLst/>
@@ -6756,28 +7028,28 @@
           <a:lstStyle/>
           <a:p>
             <a:pPr algn="l">
-              <a:defRPr sz="1600" b="1">
+              <a:defRPr sz="1400" b="1">
                 <a:solidFill>
                   <a:srgbClr val="1D1D1F"/>
                 </a:solidFill>
               </a:defRPr>
             </a:pPr>
             <a:r>
-              <a:t>Retail Training</a:t>
-            </a:r>
-          </a:p>
-        </p:txBody>
-      </p:sp>
-      <p:sp>
-        <p:nvSpPr>
-          <p:cNvPr id="12" name="TextBox 11"/>
+              <a:t>Enterprise Pitch Decks</a:t>
+            </a:r>
+          </a:p>
+        </p:txBody>
+      </p:sp>
+      <p:sp>
+        <p:nvSpPr>
+          <p:cNvPr id="7" name="TextBox 6"/>
           <p:cNvSpPr txBox="1"/>
           <p:nvPr/>
         </p:nvSpPr>
         <p:spPr>
           <a:xfrm>
-            <a:off x="4754880" y="3291840"/>
-            <a:ext cx="2926080" cy="1371600"/>
+            <a:off x="685800" y="3291840"/>
+            <a:ext cx="2194560" cy="1645920"/>
           </a:xfrm>
           <a:prstGeom prst="rect">
             <a:avLst/>
@@ -6791,28 +7063,28 @@
           <a:lstStyle/>
           <a:p>
             <a:pPr algn="l">
-              <a:defRPr sz="1200" b="0">
+              <a:defRPr sz="1000" b="0">
                 <a:solidFill>
                   <a:srgbClr val="6E6E73"/>
                 </a:solidFill>
               </a:defRPr>
             </a:pPr>
             <a:r>
-              <a:t>Equip Apple Store teams with "17 Billion Gallons Saved" talking points for customer engagement.</a:t>
-            </a:r>
-          </a:p>
-        </p:txBody>
-      </p:sp>
-      <p:sp>
-        <p:nvSpPr>
-          <p:cNvPr id="13" name="Rounded Rectangle 12"/>
+              <a:t>Integrate "100% Recycled Cobalt/Gold" and "Scope 3 Reduction" stats into B2B sales materials.</a:t>
+            </a:r>
+          </a:p>
+        </p:txBody>
+      </p:sp>
+      <p:sp>
+        <p:nvSpPr>
+          <p:cNvPr id="8" name="Rounded Rectangle 7"/>
           <p:cNvSpPr/>
           <p:nvPr/>
         </p:nvSpPr>
         <p:spPr>
           <a:xfrm>
-            <a:off x="8321040" y="1828800"/>
-            <a:ext cx="3474720" cy="3474720"/>
+            <a:off x="3337560" y="1828800"/>
+            <a:ext cx="2651760" cy="3474720"/>
           </a:xfrm>
           <a:prstGeom prst="roundRect">
             <a:avLst/>
@@ -6848,13 +7120,13 @@
       </p:sp>
       <p:sp>
         <p:nvSpPr>
-          <p:cNvPr id="14" name="Oval 13"/>
+          <p:cNvPr id="9" name="Oval 8"/>
           <p:cNvSpPr/>
           <p:nvPr/>
         </p:nvSpPr>
         <p:spPr>
           <a:xfrm>
-            <a:off x="8595360" y="2103120"/>
+            <a:off x="3611879" y="2103120"/>
             <a:ext cx="457200" cy="457200"/>
           </a:xfrm>
           <a:prstGeom prst="ellipse">
@@ -6891,13 +7163,13 @@
       </p:sp>
       <p:sp>
         <p:nvSpPr>
-          <p:cNvPr id="15" name="TextBox 14"/>
+          <p:cNvPr id="10" name="TextBox 9"/>
           <p:cNvSpPr txBox="1"/>
           <p:nvPr/>
         </p:nvSpPr>
         <p:spPr>
           <a:xfrm>
-            <a:off x="8595360" y="2148840"/>
+            <a:off x="3611879" y="2148840"/>
             <a:ext cx="457200" cy="365760"/>
           </a:xfrm>
           <a:prstGeom prst="rect">
@@ -6919,21 +7191,21 @@
               </a:defRPr>
             </a:pPr>
             <a:r>
-              <a:t>3</a:t>
-            </a:r>
-          </a:p>
-        </p:txBody>
-      </p:sp>
-      <p:sp>
-        <p:nvSpPr>
-          <p:cNvPr id="16" name="TextBox 15"/>
+              <a:t>2</a:t>
+            </a:r>
+          </a:p>
+        </p:txBody>
+      </p:sp>
+      <p:sp>
+        <p:nvSpPr>
+          <p:cNvPr id="11" name="TextBox 10"/>
           <p:cNvSpPr txBox="1"/>
           <p:nvPr/>
         </p:nvSpPr>
         <p:spPr>
           <a:xfrm>
-            <a:off x="8595360" y="2743200"/>
-            <a:ext cx="2926080" cy="457200"/>
+            <a:off x="3566160" y="2743200"/>
+            <a:ext cx="2194560" cy="457200"/>
           </a:xfrm>
           <a:prstGeom prst="rect">
             <a:avLst/>
@@ -6947,28 +7219,28 @@
           <a:lstStyle/>
           <a:p>
             <a:pPr algn="l">
-              <a:defRPr sz="1600" b="1">
+              <a:defRPr sz="1400" b="1">
                 <a:solidFill>
                   <a:srgbClr val="1D1D1F"/>
                 </a:solidFill>
               </a:defRPr>
             </a:pPr>
             <a:r>
-              <a:t>Marketing</a:t>
-            </a:r>
-          </a:p>
-        </p:txBody>
-      </p:sp>
-      <p:sp>
-        <p:nvSpPr>
-          <p:cNvPr id="17" name="TextBox 16"/>
+              <a:t>Retail Training</a:t>
+            </a:r>
+          </a:p>
+        </p:txBody>
+      </p:sp>
+      <p:sp>
+        <p:nvSpPr>
+          <p:cNvPr id="12" name="TextBox 11"/>
           <p:cNvSpPr txBox="1"/>
           <p:nvPr/>
         </p:nvSpPr>
         <p:spPr>
           <a:xfrm>
-            <a:off x="8595360" y="3291840"/>
-            <a:ext cx="2926080" cy="1371600"/>
+            <a:off x="3566160" y="3291840"/>
+            <a:ext cx="2194560" cy="1645920"/>
           </a:xfrm>
           <a:prstGeom prst="rect">
             <a:avLst/>
@@ -6982,14 +7254,396 @@
           <a:lstStyle/>
           <a:p>
             <a:pPr algn="l">
-              <a:defRPr sz="1200" b="0">
+              <a:defRPr sz="1000" b="0">
                 <a:solidFill>
                   <a:srgbClr val="6E6E73"/>
                 </a:solidFill>
               </a:defRPr>
             </a:pPr>
             <a:r>
+              <a:t>Equip Apple Store teams with "17 Billion Gallons Saved" talking points for customer engagement.</a:t>
+            </a:r>
+          </a:p>
+        </p:txBody>
+      </p:sp>
+      <p:sp>
+        <p:nvSpPr>
+          <p:cNvPr id="13" name="Rounded Rectangle 12"/>
+          <p:cNvSpPr/>
+          <p:nvPr/>
+        </p:nvSpPr>
+        <p:spPr>
+          <a:xfrm>
+            <a:off x="6217920" y="1828800"/>
+            <a:ext cx="2651760" cy="3474720"/>
+          </a:xfrm>
+          <a:prstGeom prst="roundRect">
+            <a:avLst/>
+          </a:prstGeom>
+          <a:solidFill>
+            <a:srgbClr val="F5F5F7"/>
+          </a:solidFill>
+          <a:ln>
+            <a:noFill/>
+          </a:ln>
+        </p:spPr>
+        <p:style>
+          <a:lnRef idx="1">
+            <a:schemeClr val="accent1"/>
+          </a:lnRef>
+          <a:fillRef idx="3">
+            <a:schemeClr val="accent1"/>
+          </a:fillRef>
+          <a:effectRef idx="2">
+            <a:schemeClr val="accent1"/>
+          </a:effectRef>
+          <a:fontRef idx="minor">
+            <a:schemeClr val="lt1"/>
+          </a:fontRef>
+        </p:style>
+        <p:txBody>
+          <a:bodyPr rtlCol="0" anchor="ctr"/>
+          <a:lstStyle/>
+          <a:p>
+            <a:pPr algn="ctr"/>
+          </a:p>
+        </p:txBody>
+      </p:sp>
+      <p:sp>
+        <p:nvSpPr>
+          <p:cNvPr id="14" name="Oval 13"/>
+          <p:cNvSpPr/>
+          <p:nvPr/>
+        </p:nvSpPr>
+        <p:spPr>
+          <a:xfrm>
+            <a:off x="6492240" y="2103120"/>
+            <a:ext cx="457200" cy="457200"/>
+          </a:xfrm>
+          <a:prstGeom prst="ellipse">
+            <a:avLst/>
+          </a:prstGeom>
+          <a:solidFill>
+            <a:srgbClr val="1A7F37"/>
+          </a:solidFill>
+          <a:ln>
+            <a:noFill/>
+          </a:ln>
+        </p:spPr>
+        <p:style>
+          <a:lnRef idx="1">
+            <a:schemeClr val="accent1"/>
+          </a:lnRef>
+          <a:fillRef idx="3">
+            <a:schemeClr val="accent1"/>
+          </a:fillRef>
+          <a:effectRef idx="2">
+            <a:schemeClr val="accent1"/>
+          </a:effectRef>
+          <a:fontRef idx="minor">
+            <a:schemeClr val="lt1"/>
+          </a:fontRef>
+        </p:style>
+        <p:txBody>
+          <a:bodyPr rtlCol="0" anchor="ctr"/>
+          <a:lstStyle/>
+          <a:p>
+            <a:pPr algn="ctr"/>
+          </a:p>
+        </p:txBody>
+      </p:sp>
+      <p:sp>
+        <p:nvSpPr>
+          <p:cNvPr id="15" name="TextBox 14"/>
+          <p:cNvSpPr txBox="1"/>
+          <p:nvPr/>
+        </p:nvSpPr>
+        <p:spPr>
+          <a:xfrm>
+            <a:off x="6492240" y="2148840"/>
+            <a:ext cx="457200" cy="365760"/>
+          </a:xfrm>
+          <a:prstGeom prst="rect">
+            <a:avLst/>
+          </a:prstGeom>
+          <a:noFill/>
+        </p:spPr>
+        <p:txBody>
+          <a:bodyPr wrap="square">
+            <a:spAutoFit/>
+          </a:bodyPr>
+          <a:lstStyle/>
+          <a:p>
+            <a:pPr algn="ctr">
+              <a:defRPr sz="1400" b="1">
+                <a:solidFill>
+                  <a:srgbClr val="FFFFFF"/>
+                </a:solidFill>
+              </a:defRPr>
+            </a:pPr>
+            <a:r>
+              <a:t>3</a:t>
+            </a:r>
+          </a:p>
+        </p:txBody>
+      </p:sp>
+      <p:sp>
+        <p:nvSpPr>
+          <p:cNvPr id="16" name="TextBox 15"/>
+          <p:cNvSpPr txBox="1"/>
+          <p:nvPr/>
+        </p:nvSpPr>
+        <p:spPr>
+          <a:xfrm>
+            <a:off x="6446520" y="2743200"/>
+            <a:ext cx="2194560" cy="457200"/>
+          </a:xfrm>
+          <a:prstGeom prst="rect">
+            <a:avLst/>
+          </a:prstGeom>
+          <a:noFill/>
+        </p:spPr>
+        <p:txBody>
+          <a:bodyPr wrap="square">
+            <a:spAutoFit/>
+          </a:bodyPr>
+          <a:lstStyle/>
+          <a:p>
+            <a:pPr algn="l">
+              <a:defRPr sz="1400" b="1">
+                <a:solidFill>
+                  <a:srgbClr val="1D1D1F"/>
+                </a:solidFill>
+              </a:defRPr>
+            </a:pPr>
+            <a:r>
+              <a:t>Marketing</a:t>
+            </a:r>
+          </a:p>
+        </p:txBody>
+      </p:sp>
+      <p:sp>
+        <p:nvSpPr>
+          <p:cNvPr id="17" name="TextBox 16"/>
+          <p:cNvSpPr txBox="1"/>
+          <p:nvPr/>
+        </p:nvSpPr>
+        <p:spPr>
+          <a:xfrm>
+            <a:off x="6446520" y="3291840"/>
+            <a:ext cx="2194560" cy="1645920"/>
+          </a:xfrm>
+          <a:prstGeom prst="rect">
+            <a:avLst/>
+          </a:prstGeom>
+          <a:noFill/>
+        </p:spPr>
+        <p:txBody>
+          <a:bodyPr wrap="square">
+            <a:spAutoFit/>
+          </a:bodyPr>
+          <a:lstStyle/>
+          <a:p>
+            <a:pPr algn="l">
+              <a:defRPr sz="1000" b="0">
+                <a:solidFill>
+                  <a:srgbClr val="6E6E73"/>
+                </a:solidFill>
+              </a:defRPr>
+            </a:pPr>
+            <a:r>
               <a:t>Launch a campaign highlighting the 100% plastic-free unboxing experience as a premium feature.</a:t>
+            </a:r>
+          </a:p>
+        </p:txBody>
+      </p:sp>
+      <p:sp>
+        <p:nvSpPr>
+          <p:cNvPr id="18" name="Rounded Rectangle 17"/>
+          <p:cNvSpPr/>
+          <p:nvPr/>
+        </p:nvSpPr>
+        <p:spPr>
+          <a:xfrm>
+            <a:off x="9098280" y="1828800"/>
+            <a:ext cx="2651760" cy="3474720"/>
+          </a:xfrm>
+          <a:prstGeom prst="roundRect">
+            <a:avLst/>
+          </a:prstGeom>
+          <a:solidFill>
+            <a:srgbClr val="F5F5F7"/>
+          </a:solidFill>
+          <a:ln>
+            <a:noFill/>
+          </a:ln>
+        </p:spPr>
+        <p:style>
+          <a:lnRef idx="1">
+            <a:schemeClr val="accent1"/>
+          </a:lnRef>
+          <a:fillRef idx="3">
+            <a:schemeClr val="accent1"/>
+          </a:fillRef>
+          <a:effectRef idx="2">
+            <a:schemeClr val="accent1"/>
+          </a:effectRef>
+          <a:fontRef idx="minor">
+            <a:schemeClr val="lt1"/>
+          </a:fontRef>
+        </p:style>
+        <p:txBody>
+          <a:bodyPr rtlCol="0" anchor="ctr"/>
+          <a:lstStyle/>
+          <a:p>
+            <a:pPr algn="ctr"/>
+          </a:p>
+        </p:txBody>
+      </p:sp>
+      <p:sp>
+        <p:nvSpPr>
+          <p:cNvPr id="19" name="Oval 18"/>
+          <p:cNvSpPr/>
+          <p:nvPr/>
+        </p:nvSpPr>
+        <p:spPr>
+          <a:xfrm>
+            <a:off x="9372600" y="2103120"/>
+            <a:ext cx="457200" cy="457200"/>
+          </a:xfrm>
+          <a:prstGeom prst="ellipse">
+            <a:avLst/>
+          </a:prstGeom>
+          <a:solidFill>
+            <a:srgbClr val="1A7F37"/>
+          </a:solidFill>
+          <a:ln>
+            <a:noFill/>
+          </a:ln>
+        </p:spPr>
+        <p:style>
+          <a:lnRef idx="1">
+            <a:schemeClr val="accent1"/>
+          </a:lnRef>
+          <a:fillRef idx="3">
+            <a:schemeClr val="accent1"/>
+          </a:fillRef>
+          <a:effectRef idx="2">
+            <a:schemeClr val="accent1"/>
+          </a:effectRef>
+          <a:fontRef idx="minor">
+            <a:schemeClr val="lt1"/>
+          </a:fontRef>
+        </p:style>
+        <p:txBody>
+          <a:bodyPr rtlCol="0" anchor="ctr"/>
+          <a:lstStyle/>
+          <a:p>
+            <a:pPr algn="ctr"/>
+          </a:p>
+        </p:txBody>
+      </p:sp>
+      <p:sp>
+        <p:nvSpPr>
+          <p:cNvPr id="20" name="TextBox 19"/>
+          <p:cNvSpPr txBox="1"/>
+          <p:nvPr/>
+        </p:nvSpPr>
+        <p:spPr>
+          <a:xfrm>
+            <a:off x="9372600" y="2148840"/>
+            <a:ext cx="457200" cy="365760"/>
+          </a:xfrm>
+          <a:prstGeom prst="rect">
+            <a:avLst/>
+          </a:prstGeom>
+          <a:noFill/>
+        </p:spPr>
+        <p:txBody>
+          <a:bodyPr wrap="square">
+            <a:spAutoFit/>
+          </a:bodyPr>
+          <a:lstStyle/>
+          <a:p>
+            <a:pPr algn="ctr">
+              <a:defRPr sz="1400" b="1">
+                <a:solidFill>
+                  <a:srgbClr val="FFFFFF"/>
+                </a:solidFill>
+              </a:defRPr>
+            </a:pPr>
+            <a:r>
+              <a:t>4</a:t>
+            </a:r>
+          </a:p>
+        </p:txBody>
+      </p:sp>
+      <p:sp>
+        <p:nvSpPr>
+          <p:cNvPr id="21" name="TextBox 20"/>
+          <p:cNvSpPr txBox="1"/>
+          <p:nvPr/>
+        </p:nvSpPr>
+        <p:spPr>
+          <a:xfrm>
+            <a:off x="9326880" y="2743200"/>
+            <a:ext cx="2194560" cy="457200"/>
+          </a:xfrm>
+          <a:prstGeom prst="rect">
+            <a:avLst/>
+          </a:prstGeom>
+          <a:noFill/>
+        </p:spPr>
+        <p:txBody>
+          <a:bodyPr wrap="square">
+            <a:spAutoFit/>
+          </a:bodyPr>
+          <a:lstStyle/>
+          <a:p>
+            <a:pPr algn="l">
+              <a:defRPr sz="1400" b="1">
+                <a:solidFill>
+                  <a:srgbClr val="1D1D1F"/>
+                </a:solidFill>
+              </a:defRPr>
+            </a:pPr>
+            <a:r>
+              <a:t>Merchant Services</a:t>
+            </a:r>
+          </a:p>
+        </p:txBody>
+      </p:sp>
+      <p:sp>
+        <p:nvSpPr>
+          <p:cNvPr id="22" name="TextBox 21"/>
+          <p:cNvSpPr txBox="1"/>
+          <p:nvPr/>
+        </p:nvSpPr>
+        <p:spPr>
+          <a:xfrm>
+            <a:off x="9326880" y="3291840"/>
+            <a:ext cx="2194560" cy="1645920"/>
+          </a:xfrm>
+          <a:prstGeom prst="rect">
+            <a:avLst/>
+          </a:prstGeom>
+          <a:noFill/>
+        </p:spPr>
+        <p:txBody>
+          <a:bodyPr wrap="square">
+            <a:spAutoFit/>
+          </a:bodyPr>
+          <a:lstStyle/>
+          <a:p>
+            <a:pPr algn="l">
+              <a:defRPr sz="1000" b="0">
+                <a:solidFill>
+                  <a:srgbClr val="6E6E73"/>
+                </a:solidFill>
+              </a:defRPr>
+            </a:pPr>
+            <a:r>
+              <a:t>Onboard sellers to Tap to Pay on iPhone Air — apple.com/shop/buy-iphone/iphone-air</a:t>
             </a:r>
           </a:p>
         </p:txBody>

</xml_diff>